<commit_message>
updated Secure Settings - Identify Options training presentation and references files (stale reference link)
</commit_message>
<xml_diff>
--- a/training/secure settings - identify options/secure settings - identify options - presentation.pptx
+++ b/training/secure settings - identify options/secure settings - identify options - presentation.pptx
@@ -34,8 +34,8 @@
     <p:sldId id="488" r:id="rId25"/>
     <p:sldId id="604" r:id="rId26"/>
     <p:sldId id="343" r:id="rId27"/>
-    <p:sldId id="606" r:id="rId28"/>
-    <p:sldId id="461" r:id="rId29"/>
+    <p:sldId id="657" r:id="rId28"/>
+    <p:sldId id="676" r:id="rId29"/>
     <p:sldId id="420" r:id="rId30"/>
     <p:sldId id="368" r:id="rId31"/>
   </p:sldIdLst>
@@ -50,11 +50,9 @@
       <p:boldItalic r:id="rId36"/>
     </p:embeddedFont>
     <p:embeddedFont>
-      <p:font typeface="Roboto Medium" panose="020F0502020204030204" pitchFamily="34" charset="0"/>
+      <p:font typeface="Roboto Medium" panose="02000000000000000000" pitchFamily="2" charset="0"/>
       <p:regular r:id="rId37"/>
-      <p:bold r:id="rId38"/>
-      <p:italic r:id="rId39"/>
-      <p:boldItalic r:id="rId40"/>
+      <p:italic r:id="rId38"/>
     </p:embeddedFont>
   </p:embeddedFontLst>
   <p:defaultTextStyle>
@@ -8526,13 +8524,6 @@
             </a:pathLst>
           </a:custGeom>
         </p:spPr>
-        <p:txBody>
-          <a:bodyPr/>
-          <a:lstStyle/>
-          <a:p>
-            <a:endParaRPr lang="en-US"/>
-          </a:p>
-        </p:txBody>
       </p:sp>
       <p:sp>
         <p:nvSpPr>
@@ -8799,13 +8790,6 @@
             </a:pathLst>
           </a:custGeom>
         </p:spPr>
-        <p:txBody>
-          <a:bodyPr/>
-          <a:lstStyle/>
-          <a:p>
-            <a:endParaRPr lang="en-US"/>
-          </a:p>
-        </p:txBody>
       </p:sp>
       <p:sp>
         <p:nvSpPr>
@@ -8897,7 +8881,7 @@
             </a:pPr>
             <a:r>
               <a:rPr lang="en-US" dirty="0"/>
-              <a:t>It's important to note that all AVCDL materials except for the introductory blog posts are intended for product cybersecurity engineering practitioners.</a:t>
+              <a:t>It's important to note that all AVCDL materials with the exception of the introductory blog posts are intended for product cybersecurity engineering practitioners.</a:t>
             </a:r>
           </a:p>
           <a:p>
@@ -20764,8 +20748,8 @@
         </p:nvSpPr>
         <p:spPr>
           <a:xfrm>
-            <a:off x="10741248" y="5270394"/>
-            <a:ext cx="963725" cy="461665"/>
+            <a:off x="10741247" y="5270394"/>
+            <a:ext cx="963726" cy="461665"/>
           </a:xfrm>
           <a:prstGeom prst="rect">
             <a:avLst/>
@@ -20789,7 +20773,7 @@
                 <a:latin typeface="Roboto" panose="02000000000000000000" pitchFamily="2" charset="0"/>
                 <a:ea typeface="Roboto" panose="02000000000000000000" pitchFamily="2" charset="0"/>
               </a:rPr>
-              <a:t>version 2</a:t>
+              <a:t>version 3</a:t>
             </a:r>
           </a:p>
           <a:p>
@@ -20805,7 +20789,7 @@
                 <a:latin typeface="Roboto" panose="02000000000000000000" pitchFamily="2" charset="0"/>
                 <a:ea typeface="Roboto" panose="02000000000000000000" pitchFamily="2" charset="0"/>
               </a:rPr>
-              <a:t>2025-09-11</a:t>
+              <a:t>2026-07-09</a:t>
             </a:r>
           </a:p>
         </p:txBody>
@@ -23862,14 +23846,13 @@
         </p:nvPicPr>
         <p:blipFill>
           <a:blip r:embed="rId3"/>
-          <a:stretch>
-            <a:fillRect/>
-          </a:stretch>
+          <a:srcRect/>
+          <a:stretch/>
         </p:blipFill>
         <p:spPr>
           <a:xfrm>
             <a:off x="741952" y="326959"/>
-            <a:ext cx="10704920" cy="6204081"/>
+            <a:ext cx="10704919" cy="6204081"/>
           </a:xfrm>
           <a:prstGeom prst="rect">
             <a:avLst/>
@@ -24577,7 +24560,7 @@
       </p:grpSpPr>
       <p:pic>
         <p:nvPicPr>
-          <p:cNvPr id="4" name="Picture 3" descr="A screenshot of a computer&#10;&#10;AI-generated content may be incorrect.">
+          <p:cNvPr id="4" name="Picture 3">
             <a:extLst>
               <a:ext uri="{FF2B5EF4-FFF2-40B4-BE49-F238E27FC236}">
                 <a16:creationId xmlns:a16="http://schemas.microsoft.com/office/drawing/2014/main" id="{C2A2ADBF-13F1-8937-91E4-97FBA4F83BB0}"/>
@@ -24591,14 +24574,13 @@
         </p:nvPicPr>
         <p:blipFill>
           <a:blip r:embed="rId3"/>
-          <a:stretch>
-            <a:fillRect/>
-          </a:stretch>
+          <a:srcRect/>
+          <a:stretch/>
         </p:blipFill>
         <p:spPr>
           <a:xfrm>
-            <a:off x="1573706" y="985083"/>
-            <a:ext cx="9041411" cy="5778453"/>
+            <a:off x="1813953" y="985083"/>
+            <a:ext cx="8560918" cy="5778453"/>
           </a:xfrm>
           <a:prstGeom prst="rect">
             <a:avLst/>
@@ -24703,7 +24685,7 @@
     </p:spTree>
     <p:extLst>
       <p:ext uri="{BB962C8B-B14F-4D97-AF65-F5344CB8AC3E}">
-        <p14:creationId xmlns:p14="http://schemas.microsoft.com/office/powerpoint/2010/main" val="2993404108"/>
+        <p14:creationId xmlns:p14="http://schemas.microsoft.com/office/powerpoint/2010/main" val="3182285050"/>
       </p:ext>
     </p:extLst>
   </p:cSld>
@@ -24732,7 +24714,7 @@
       </p:grpSpPr>
       <p:pic>
         <p:nvPicPr>
-          <p:cNvPr id="4" name="Picture 3" descr="A screenshot of a computer&#10;&#10;AI-generated content may be incorrect.">
+          <p:cNvPr id="4" name="Picture 3">
             <a:extLst>
               <a:ext uri="{FF2B5EF4-FFF2-40B4-BE49-F238E27FC236}">
                 <a16:creationId xmlns:a16="http://schemas.microsoft.com/office/drawing/2014/main" id="{24875B67-DABD-EC7D-D876-FF0A75BC967B}"/>
@@ -24746,14 +24728,13 @@
         </p:nvPicPr>
         <p:blipFill>
           <a:blip r:embed="rId3"/>
-          <a:stretch>
-            <a:fillRect/>
-          </a:stretch>
+          <a:srcRect/>
+          <a:stretch/>
         </p:blipFill>
         <p:spPr>
           <a:xfrm>
             <a:off x="1658351" y="985083"/>
-            <a:ext cx="8483870" cy="5783298"/>
+            <a:ext cx="8483870" cy="5763705"/>
           </a:xfrm>
           <a:prstGeom prst="rect">
             <a:avLst/>
@@ -24866,7 +24847,7 @@
     </p:spTree>
     <p:extLst>
       <p:ext uri="{BB962C8B-B14F-4D97-AF65-F5344CB8AC3E}">
-        <p14:creationId xmlns:p14="http://schemas.microsoft.com/office/powerpoint/2010/main" val="4071491532"/>
+        <p14:creationId xmlns:p14="http://schemas.microsoft.com/office/powerpoint/2010/main" val="3883577190"/>
       </p:ext>
     </p:extLst>
   </p:cSld>
@@ -24933,10 +24914,10 @@
       </p:sp>
       <p:pic>
         <p:nvPicPr>
-          <p:cNvPr id="7" name="Picture 6">
+          <p:cNvPr id="2" name="Picture 1">
             <a:extLst>
               <a:ext uri="{FF2B5EF4-FFF2-40B4-BE49-F238E27FC236}">
-                <a16:creationId xmlns:a16="http://schemas.microsoft.com/office/drawing/2014/main" id="{C52B1944-9D2E-B660-DF63-98B36A597D37}"/>
+                <a16:creationId xmlns:a16="http://schemas.microsoft.com/office/drawing/2014/main" id="{4E104AA9-51D2-EA36-2A63-2E32B6E40504}"/>
               </a:ext>
             </a:extLst>
           </p:cNvPr>
@@ -24947,14 +24928,13 @@
         </p:nvPicPr>
         <p:blipFill>
           <a:blip r:embed="rId3"/>
-          <a:stretch>
-            <a:fillRect/>
-          </a:stretch>
+          <a:srcRect/>
+          <a:stretch/>
         </p:blipFill>
         <p:spPr>
           <a:xfrm>
             <a:off x="741952" y="326959"/>
-            <a:ext cx="10704920" cy="6204081"/>
+            <a:ext cx="10704919" cy="6204081"/>
           </a:xfrm>
           <a:prstGeom prst="rect">
             <a:avLst/>
@@ -25425,7 +25405,7 @@
                 <a:cs typeface="Courier New" panose="02070309020205020404" pitchFamily="49" charset="0"/>
                 <a:hlinkClick r:id="rId4"/>
               </a:rPr>
-              <a:t>https://usnistgov.github.io/BF/info/bf-classes/overview/</a:t>
+              <a:t>https://usnistgov.github.io/BF</a:t>
             </a:r>
             <a:r>
               <a:rPr lang="en-US" sz="1400" b="1" dirty="0">

</xml_diff>